<commit_message>
Jugadas en español (en curso)
Co-Authored-By: Claude Opus 5.5 <noreply@anthropic.com>
Claude-Session: https://claude.ai/code/session_019kpJgFy6kSQESjpjr1aZo4
</commit_message>
<xml_diff>
--- a/cursos/recursos/aperturas-y-defensas/06-defensa-nimzoindia.pptx
+++ b/cursos/recursos/aperturas-y-defensas/06-defensa-nimzoindia.pptx
@@ -1602,7 +1602,7 @@
                 <a:ea typeface="Calibri" pitchFamily="34" charset="-122"/>
                 <a:cs typeface="Calibri" pitchFamily="34" charset="-120"/>
               </a:rPr>
-              <a:t>1.d4 Nf6 2.c4 e6 3.Nc3 Bb4 clava al caballo c3 y amenaza doblarle los peones a blancas si captura.</a:t>
+              <a:t>1.d4 Cf6 2.c4 e6 3.Cc3 Ab4 clava al caballo c3 y amenaza doblarle los peones a blancas si captura.</a:t>
             </a:r>
             <a:endParaRPr lang="en-US" sz="1600" dirty="0"/>
           </a:p>
@@ -1626,7 +1626,7 @@
                 <a:ea typeface="Calibri" pitchFamily="34" charset="-122"/>
                 <a:cs typeface="Calibri" pitchFamily="34" charset="-120"/>
               </a:rPr>
-              <a:t>Blancas suele responder con 4.e3, 4.Qc2 o 4.Nf3, y a menudo termina aceptando peones doblados en c3 a cambio de la pareja de alfiles y un centro amplio.</a:t>
+              <a:t>Blancas suele responder con 4.e3, 4.Dc2 o 4.Cf3, y a menudo termina aceptando peones doblados en c3 a cambio de la pareja de alfiles y un centro amplio.</a:t>
             </a:r>
             <a:endParaRPr lang="en-US" sz="1600" dirty="0"/>
           </a:p>

</xml_diff>